<commit_message>
updating agenda and ppt for class 12
</commit_message>
<xml_diff>
--- a/docs/lectures/in-class_activities/class_12.pptx
+++ b/docs/lectures/in-class_activities/class_12.pptx
@@ -5,17 +5,15 @@
     <p:sldMasterId id="2147483648" r:id="rId1"/>
   </p:sldMasterIdLst>
   <p:notesMasterIdLst>
-    <p:notesMasterId r:id="rId10"/>
+    <p:notesMasterId r:id="rId8"/>
   </p:notesMasterIdLst>
   <p:sldIdLst>
     <p:sldId id="480" r:id="rId2"/>
     <p:sldId id="723" r:id="rId3"/>
-    <p:sldId id="1554" r:id="rId4"/>
-    <p:sldId id="712" r:id="rId5"/>
-    <p:sldId id="1556" r:id="rId6"/>
-    <p:sldId id="714" r:id="rId7"/>
-    <p:sldId id="675" r:id="rId8"/>
-    <p:sldId id="1555" r:id="rId9"/>
+    <p:sldId id="712" r:id="rId4"/>
+    <p:sldId id="1557" r:id="rId5"/>
+    <p:sldId id="714" r:id="rId6"/>
+    <p:sldId id="1555" r:id="rId7"/>
   </p:sldIdLst>
   <p:sldSz cx="12192000" cy="6858000"/>
   <p:notesSz cx="6858000" cy="9144000"/>
@@ -204,7 +202,7 @@
           <a:p>
             <a:fld id="{6AC7DB66-C6D6-B24E-B345-FA3772C924EA}" type="datetimeFigureOut">
               <a:rPr lang="en-US" smtClean="0"/>
-              <a:t>10/27/21</a:t>
+              <a:t>10/24/25</a:t>
             </a:fld>
             <a:endParaRPr lang="en-US"/>
           </a:p>
@@ -683,24 +681,7 @@
           <a:bodyPr/>
           <a:lstStyle/>
           <a:p>
-            <a:endParaRPr lang="en-US" dirty="0"/>
-          </a:p>
-          <a:p>
-            <a:r>
-              <a:rPr lang="en-US" dirty="0"/>
-              <a:t>Changes in any attribute of a population over time. </a:t>
-            </a:r>
-          </a:p>
-          <a:p>
-            <a:r>
-              <a:rPr lang="en-US" dirty="0"/>
-              <a:t>Evolutionary</a:t>
-            </a:r>
-            <a:r>
-              <a:rPr lang="en-US" baseline="0" dirty="0"/>
-              <a:t> change leads to adaptation and must involve a change in the frequency of individual genes in a population from generation to generation.</a:t>
-            </a:r>
-            <a:endParaRPr lang="en-US" dirty="0"/>
+            <a:endParaRPr lang="en-US"/>
           </a:p>
         </p:txBody>
       </p:sp>
@@ -711,7 +692,7 @@
             <a:spLocks noGrp="1"/>
           </p:cNvSpPr>
           <p:nvPr>
-            <p:ph type="sldNum" sz="quarter" idx="10"/>
+            <p:ph type="sldNum" sz="quarter" idx="5"/>
           </p:nvPr>
         </p:nvSpPr>
         <p:spPr/>
@@ -719,14 +700,8 @@
           <a:bodyPr/>
           <a:lstStyle/>
           <a:p>
-            <a:pPr>
-              <a:defRPr/>
-            </a:pPr>
-            <a:fld id="{217FB9E2-7C0C-AB45-B0B4-06C6B1BD2B82}" type="slidenum">
+            <a:fld id="{4218707C-A528-5347-B512-111D9A72273A}" type="slidenum">
               <a:rPr lang="en-US" smtClean="0"/>
-              <a:pPr>
-                <a:defRPr/>
-              </a:pPr>
               <a:t>3</a:t>
             </a:fld>
             <a:endParaRPr lang="en-US"/>
@@ -736,7 +711,7 @@
     </p:spTree>
     <p:extLst>
       <p:ext uri="{BB962C8B-B14F-4D97-AF65-F5344CB8AC3E}">
-        <p14:creationId xmlns:p14="http://schemas.microsoft.com/office/powerpoint/2010/main" val="1400352488"/>
+        <p14:creationId xmlns:p14="http://schemas.microsoft.com/office/powerpoint/2010/main" val="3944686282"/>
       </p:ext>
     </p:extLst>
   </p:cSld>
@@ -790,7 +765,18 @@
           <a:bodyPr/>
           <a:lstStyle/>
           <a:p>
-            <a:endParaRPr lang="en-US"/>
+            <a:r>
+              <a:rPr lang="en-US"/>
+              <a:t>Do not modify the notes in this section to avoid tampering with the Poll Everywhere activity.
+More info at polleverywhere.com/support
+What measures would you have put in place to protect against LF transmission?</a:t>
+            </a:r>
+          </a:p>
+          <a:p>
+            <a:r>
+              <a:rPr lang="en-US"/>
+              <a:t>https://www.polleverywhere.com/discourses/oI4gPMkToAhAFAKFma6Sx</a:t>
+            </a:r>
           </a:p>
         </p:txBody>
       </p:sp>
@@ -820,7 +806,7 @@
     </p:spTree>
     <p:extLst>
       <p:ext uri="{BB962C8B-B14F-4D97-AF65-F5344CB8AC3E}">
-        <p14:creationId xmlns:p14="http://schemas.microsoft.com/office/powerpoint/2010/main" val="3944686282"/>
+        <p14:creationId xmlns:p14="http://schemas.microsoft.com/office/powerpoint/2010/main" val="1402942129"/>
       </p:ext>
     </p:extLst>
   </p:cSld>
@@ -874,16 +860,7 @@
           <a:bodyPr/>
           <a:lstStyle/>
           <a:p>
-            <a:r>
-              <a:rPr lang="en-US"/>
-              <a:t>What measures would you have put in place to protect against LF transmission?</a:t>
-            </a:r>
-          </a:p>
-          <a:p>
-            <a:r>
-              <a:rPr lang="en-US"/>
-              <a:t>https://www.polleverywhere.com/discourses/4S7u0o0hpXopHlnMc1ArI</a:t>
-            </a:r>
+            <a:endParaRPr lang="en-US"/>
           </a:p>
         </p:txBody>
       </p:sp>
@@ -913,7 +890,7 @@
     </p:spTree>
     <p:extLst>
       <p:ext uri="{BB962C8B-B14F-4D97-AF65-F5344CB8AC3E}">
-        <p14:creationId xmlns:p14="http://schemas.microsoft.com/office/powerpoint/2010/main" val="213626519"/>
+        <p14:creationId xmlns:p14="http://schemas.microsoft.com/office/powerpoint/2010/main" val="3214791753"/>
       </p:ext>
     </p:extLst>
   </p:cSld>
@@ -989,197 +966,6 @@
             <a:fld id="{4218707C-A528-5347-B512-111D9A72273A}" type="slidenum">
               <a:rPr lang="en-US" smtClean="0"/>
               <a:t>6</a:t>
-            </a:fld>
-            <a:endParaRPr lang="en-US"/>
-          </a:p>
-        </p:txBody>
-      </p:sp>
-    </p:spTree>
-    <p:extLst>
-      <p:ext uri="{BB962C8B-B14F-4D97-AF65-F5344CB8AC3E}">
-        <p14:creationId xmlns:p14="http://schemas.microsoft.com/office/powerpoint/2010/main" val="3214791753"/>
-      </p:ext>
-    </p:extLst>
-  </p:cSld>
-  <p:clrMapOvr>
-    <a:masterClrMapping/>
-  </p:clrMapOvr>
-</p:notes>
-</file>
-
-<file path=ppt/notesSlides/notesSlide7.xml><?xml version="1.0" encoding="utf-8"?>
-<p:notes xmlns:a="http://schemas.openxmlformats.org/drawingml/2006/main" xmlns:r="http://schemas.openxmlformats.org/officeDocument/2006/relationships" xmlns:p="http://schemas.openxmlformats.org/presentationml/2006/main">
-  <p:cSld>
-    <p:spTree>
-      <p:nvGrpSpPr>
-        <p:cNvPr id="1" name=""/>
-        <p:cNvGrpSpPr/>
-        <p:nvPr/>
-      </p:nvGrpSpPr>
-      <p:grpSpPr>
-        <a:xfrm>
-          <a:off x="0" y="0"/>
-          <a:ext cx="0" cy="0"/>
-          <a:chOff x="0" y="0"/>
-          <a:chExt cx="0" cy="0"/>
-        </a:xfrm>
-      </p:grpSpPr>
-      <p:sp>
-        <p:nvSpPr>
-          <p:cNvPr id="2" name="Slide Image Placeholder 1"/>
-          <p:cNvSpPr>
-            <a:spLocks noGrp="1" noRot="1" noChangeAspect="1"/>
-          </p:cNvSpPr>
-          <p:nvPr>
-            <p:ph type="sldImg"/>
-          </p:nvPr>
-        </p:nvSpPr>
-        <p:spPr/>
-      </p:sp>
-      <p:sp>
-        <p:nvSpPr>
-          <p:cNvPr id="3" name="Notes Placeholder 2"/>
-          <p:cNvSpPr>
-            <a:spLocks noGrp="1"/>
-          </p:cNvSpPr>
-          <p:nvPr>
-            <p:ph type="body" idx="1"/>
-          </p:nvPr>
-        </p:nvSpPr>
-        <p:spPr/>
-        <p:txBody>
-          <a:bodyPr/>
-          <a:lstStyle/>
-          <a:p>
-            <a:endParaRPr lang="en-US" dirty="0"/>
-          </a:p>
-          <a:p>
-            <a:r>
-              <a:rPr lang="en-US" dirty="0"/>
-              <a:t>Changes in any attribute of a population over time. </a:t>
-            </a:r>
-          </a:p>
-          <a:p>
-            <a:r>
-              <a:rPr lang="en-US" dirty="0"/>
-              <a:t>Evolutionary</a:t>
-            </a:r>
-            <a:r>
-              <a:rPr lang="en-US" baseline="0" dirty="0"/>
-              <a:t> change leads to adaptation and must involve a change in the frequency of individual genes in a population from generation to generation.</a:t>
-            </a:r>
-            <a:endParaRPr lang="en-US" dirty="0"/>
-          </a:p>
-        </p:txBody>
-      </p:sp>
-      <p:sp>
-        <p:nvSpPr>
-          <p:cNvPr id="4" name="Slide Number Placeholder 3"/>
-          <p:cNvSpPr>
-            <a:spLocks noGrp="1"/>
-          </p:cNvSpPr>
-          <p:nvPr>
-            <p:ph type="sldNum" sz="quarter" idx="10"/>
-          </p:nvPr>
-        </p:nvSpPr>
-        <p:spPr/>
-        <p:txBody>
-          <a:bodyPr/>
-          <a:lstStyle/>
-          <a:p>
-            <a:pPr>
-              <a:defRPr/>
-            </a:pPr>
-            <a:fld id="{217FB9E2-7C0C-AB45-B0B4-06C6B1BD2B82}" type="slidenum">
-              <a:rPr lang="en-US" smtClean="0"/>
-              <a:pPr>
-                <a:defRPr/>
-              </a:pPr>
-              <a:t>7</a:t>
-            </a:fld>
-            <a:endParaRPr lang="en-US"/>
-          </a:p>
-        </p:txBody>
-      </p:sp>
-    </p:spTree>
-    <p:extLst>
-      <p:ext uri="{BB962C8B-B14F-4D97-AF65-F5344CB8AC3E}">
-        <p14:creationId xmlns:p14="http://schemas.microsoft.com/office/powerpoint/2010/main" val="71014221"/>
-      </p:ext>
-    </p:extLst>
-  </p:cSld>
-  <p:clrMapOvr>
-    <a:masterClrMapping/>
-  </p:clrMapOvr>
-</p:notes>
-</file>
-
-<file path=ppt/notesSlides/notesSlide8.xml><?xml version="1.0" encoding="utf-8"?>
-<p:notes xmlns:a="http://schemas.openxmlformats.org/drawingml/2006/main" xmlns:r="http://schemas.openxmlformats.org/officeDocument/2006/relationships" xmlns:p="http://schemas.openxmlformats.org/presentationml/2006/main">
-  <p:cSld>
-    <p:spTree>
-      <p:nvGrpSpPr>
-        <p:cNvPr id="1" name=""/>
-        <p:cNvGrpSpPr/>
-        <p:nvPr/>
-      </p:nvGrpSpPr>
-      <p:grpSpPr>
-        <a:xfrm>
-          <a:off x="0" y="0"/>
-          <a:ext cx="0" cy="0"/>
-          <a:chOff x="0" y="0"/>
-          <a:chExt cx="0" cy="0"/>
-        </a:xfrm>
-      </p:grpSpPr>
-      <p:sp>
-        <p:nvSpPr>
-          <p:cNvPr id="2" name="Slide Image Placeholder 1"/>
-          <p:cNvSpPr>
-            <a:spLocks noGrp="1" noRot="1" noChangeAspect="1"/>
-          </p:cNvSpPr>
-          <p:nvPr>
-            <p:ph type="sldImg"/>
-          </p:nvPr>
-        </p:nvSpPr>
-        <p:spPr/>
-      </p:sp>
-      <p:sp>
-        <p:nvSpPr>
-          <p:cNvPr id="3" name="Notes Placeholder 2"/>
-          <p:cNvSpPr>
-            <a:spLocks noGrp="1"/>
-          </p:cNvSpPr>
-          <p:nvPr>
-            <p:ph type="body" idx="1"/>
-          </p:nvPr>
-        </p:nvSpPr>
-        <p:spPr/>
-        <p:txBody>
-          <a:bodyPr/>
-          <a:lstStyle/>
-          <a:p>
-            <a:endParaRPr lang="en-US"/>
-          </a:p>
-        </p:txBody>
-      </p:sp>
-      <p:sp>
-        <p:nvSpPr>
-          <p:cNvPr id="4" name="Slide Number Placeholder 3"/>
-          <p:cNvSpPr>
-            <a:spLocks noGrp="1"/>
-          </p:cNvSpPr>
-          <p:nvPr>
-            <p:ph type="sldNum" sz="quarter" idx="5"/>
-          </p:nvPr>
-        </p:nvSpPr>
-        <p:spPr/>
-        <p:txBody>
-          <a:bodyPr/>
-          <a:lstStyle/>
-          <a:p>
-            <a:fld id="{4218707C-A528-5347-B512-111D9A72273A}" type="slidenum">
-              <a:rPr lang="en-US" smtClean="0"/>
-              <a:t>8</a:t>
             </a:fld>
             <a:endParaRPr lang="en-US"/>
           </a:p>
@@ -1345,7 +1131,7 @@
           <a:p>
             <a:fld id="{21DDE3A9-9D48-7D40-AF95-520AE186EA5D}" type="datetimeFigureOut">
               <a:rPr lang="en-US" smtClean="0"/>
-              <a:t>10/27/21</a:t>
+              <a:t>10/24/25</a:t>
             </a:fld>
             <a:endParaRPr lang="en-US"/>
           </a:p>
@@ -1543,7 +1329,7 @@
           <a:p>
             <a:fld id="{21DDE3A9-9D48-7D40-AF95-520AE186EA5D}" type="datetimeFigureOut">
               <a:rPr lang="en-US" smtClean="0"/>
-              <a:t>10/27/21</a:t>
+              <a:t>10/24/25</a:t>
             </a:fld>
             <a:endParaRPr lang="en-US"/>
           </a:p>
@@ -1751,7 +1537,7 @@
           <a:p>
             <a:fld id="{21DDE3A9-9D48-7D40-AF95-520AE186EA5D}" type="datetimeFigureOut">
               <a:rPr lang="en-US" smtClean="0"/>
-              <a:t>10/27/21</a:t>
+              <a:t>10/24/25</a:t>
             </a:fld>
             <a:endParaRPr lang="en-US"/>
           </a:p>
@@ -1949,7 +1735,7 @@
           <a:p>
             <a:fld id="{21DDE3A9-9D48-7D40-AF95-520AE186EA5D}" type="datetimeFigureOut">
               <a:rPr lang="en-US" smtClean="0"/>
-              <a:t>10/27/21</a:t>
+              <a:t>10/24/25</a:t>
             </a:fld>
             <a:endParaRPr lang="en-US"/>
           </a:p>
@@ -2224,7 +2010,7 @@
           <a:p>
             <a:fld id="{21DDE3A9-9D48-7D40-AF95-520AE186EA5D}" type="datetimeFigureOut">
               <a:rPr lang="en-US" smtClean="0"/>
-              <a:t>10/27/21</a:t>
+              <a:t>10/24/25</a:t>
             </a:fld>
             <a:endParaRPr lang="en-US"/>
           </a:p>
@@ -2489,7 +2275,7 @@
           <a:p>
             <a:fld id="{21DDE3A9-9D48-7D40-AF95-520AE186EA5D}" type="datetimeFigureOut">
               <a:rPr lang="en-US" smtClean="0"/>
-              <a:t>10/27/21</a:t>
+              <a:t>10/24/25</a:t>
             </a:fld>
             <a:endParaRPr lang="en-US"/>
           </a:p>
@@ -2901,7 +2687,7 @@
           <a:p>
             <a:fld id="{21DDE3A9-9D48-7D40-AF95-520AE186EA5D}" type="datetimeFigureOut">
               <a:rPr lang="en-US" smtClean="0"/>
-              <a:t>10/27/21</a:t>
+              <a:t>10/24/25</a:t>
             </a:fld>
             <a:endParaRPr lang="en-US"/>
           </a:p>
@@ -3042,7 +2828,7 @@
           <a:p>
             <a:fld id="{21DDE3A9-9D48-7D40-AF95-520AE186EA5D}" type="datetimeFigureOut">
               <a:rPr lang="en-US" smtClean="0"/>
-              <a:t>10/27/21</a:t>
+              <a:t>10/24/25</a:t>
             </a:fld>
             <a:endParaRPr lang="en-US"/>
           </a:p>
@@ -3155,7 +2941,7 @@
           <a:p>
             <a:fld id="{21DDE3A9-9D48-7D40-AF95-520AE186EA5D}" type="datetimeFigureOut">
               <a:rPr lang="en-US" smtClean="0"/>
-              <a:t>10/27/21</a:t>
+              <a:t>10/24/25</a:t>
             </a:fld>
             <a:endParaRPr lang="en-US"/>
           </a:p>
@@ -3466,7 +3252,7 @@
           <a:p>
             <a:fld id="{21DDE3A9-9D48-7D40-AF95-520AE186EA5D}" type="datetimeFigureOut">
               <a:rPr lang="en-US" smtClean="0"/>
-              <a:t>10/27/21</a:t>
+              <a:t>10/24/25</a:t>
             </a:fld>
             <a:endParaRPr lang="en-US"/>
           </a:p>
@@ -3754,7 +3540,7 @@
           <a:p>
             <a:fld id="{21DDE3A9-9D48-7D40-AF95-520AE186EA5D}" type="datetimeFigureOut">
               <a:rPr lang="en-US" smtClean="0"/>
-              <a:t>10/27/21</a:t>
+              <a:t>10/24/25</a:t>
             </a:fld>
             <a:endParaRPr lang="en-US"/>
           </a:p>
@@ -3995,7 +3781,7 @@
           <a:p>
             <a:fld id="{21DDE3A9-9D48-7D40-AF95-520AE186EA5D}" type="datetimeFigureOut">
               <a:rPr lang="en-US" smtClean="0"/>
-              <a:t>10/27/21</a:t>
+              <a:t>10/24/25</a:t>
             </a:fld>
             <a:endParaRPr lang="en-US"/>
           </a:p>
@@ -4464,7 +4250,7 @@
                 <a:latin typeface="Avenir Book" panose="02000503020000020003" pitchFamily="2" charset="0"/>
                 <a:cs typeface="Avenir"/>
               </a:rPr>
-              <a:t>Practical session 12</a:t>
+              <a:t>Class 12</a:t>
             </a:r>
             <a:r>
               <a:rPr lang="en-US" sz="4800" dirty="0">
@@ -4933,131 +4719,6 @@
           <a:chExt cx="0" cy="0"/>
         </a:xfrm>
       </p:grpSpPr>
-      <p:pic>
-        <p:nvPicPr>
-          <p:cNvPr id="5" name="Picture 4">
-            <a:extLst>
-              <a:ext uri="{FF2B5EF4-FFF2-40B4-BE49-F238E27FC236}">
-                <a16:creationId xmlns:a16="http://schemas.microsoft.com/office/drawing/2014/main" id="{C8F37AE3-B782-4641-8C9A-7A9115E2FD8D}"/>
-              </a:ext>
-            </a:extLst>
-          </p:cNvPr>
-          <p:cNvPicPr>
-            <a:picLocks noChangeAspect="1"/>
-          </p:cNvPicPr>
-          <p:nvPr/>
-        </p:nvPicPr>
-        <p:blipFill rotWithShape="1">
-          <a:blip r:embed="rId3"/>
-          <a:srcRect l="6978" t="6285" r="7095" b="7757"/>
-          <a:stretch/>
-        </p:blipFill>
-        <p:spPr>
-          <a:xfrm>
-            <a:off x="1128713" y="128588"/>
-            <a:ext cx="9929812" cy="6615541"/>
-          </a:xfrm>
-          <a:prstGeom prst="rect">
-            <a:avLst/>
-          </a:prstGeom>
-        </p:spPr>
-      </p:pic>
-      <p:sp>
-        <p:nvSpPr>
-          <p:cNvPr id="6" name="Rectangle 5">
-            <a:extLst>
-              <a:ext uri="{FF2B5EF4-FFF2-40B4-BE49-F238E27FC236}">
-                <a16:creationId xmlns:a16="http://schemas.microsoft.com/office/drawing/2014/main" id="{27F3D87A-B5EC-A348-970C-4C85C70B1ECF}"/>
-              </a:ext>
-            </a:extLst>
-          </p:cNvPr>
-          <p:cNvSpPr>
-            <a:spLocks noChangeArrowheads="1"/>
-          </p:cNvSpPr>
-          <p:nvPr/>
-        </p:nvSpPr>
-        <p:spPr bwMode="auto">
-          <a:xfrm>
-            <a:off x="541339" y="347842"/>
-            <a:ext cx="11109322" cy="1169551"/>
-          </a:xfrm>
-          <a:prstGeom prst="rect">
-            <a:avLst/>
-          </a:prstGeom>
-          <a:noFill/>
-          <a:ln w="9525">
-            <a:noFill/>
-            <a:miter lim="800000"/>
-            <a:headEnd/>
-            <a:tailEnd/>
-          </a:ln>
-          <a:effectLst/>
-        </p:spPr>
-        <p:txBody>
-          <a:bodyPr wrap="square">
-            <a:spAutoFit/>
-          </a:bodyPr>
-          <a:lstStyle/>
-          <a:p>
-            <a:pPr algn="ctr">
-              <a:defRPr/>
-            </a:pPr>
-            <a:r>
-              <a:rPr lang="en-US" sz="3500" b="1" dirty="0">
-                <a:latin typeface="Avenir"/>
-                <a:cs typeface="Avenir"/>
-              </a:rPr>
-              <a:t>Q1. why does an aquatic parasite </a:t>
-            </a:r>
-          </a:p>
-          <a:p>
-            <a:pPr algn="ctr">
-              <a:defRPr/>
-            </a:pPr>
-            <a:r>
-              <a:rPr lang="en-US" sz="3500" b="1" dirty="0">
-                <a:latin typeface="Avenir"/>
-                <a:cs typeface="Avenir"/>
-              </a:rPr>
-              <a:t>exist in a desert?</a:t>
-            </a:r>
-            <a:endParaRPr lang="en-US" sz="3500" b="1" i="1" dirty="0">
-              <a:latin typeface="Avenir"/>
-              <a:cs typeface="Avenir"/>
-            </a:endParaRPr>
-          </a:p>
-        </p:txBody>
-      </p:sp>
-    </p:spTree>
-    <p:extLst>
-      <p:ext uri="{BB962C8B-B14F-4D97-AF65-F5344CB8AC3E}">
-        <p14:creationId xmlns:p14="http://schemas.microsoft.com/office/powerpoint/2010/main" val="2316116945"/>
-      </p:ext>
-    </p:extLst>
-  </p:cSld>
-  <p:clrMapOvr>
-    <a:masterClrMapping/>
-  </p:clrMapOvr>
-</p:sld>
-</file>
-
-<file path=ppt/slides/slide4.xml><?xml version="1.0" encoding="utf-8"?>
-<p:sld xmlns:a="http://schemas.openxmlformats.org/drawingml/2006/main" xmlns:r="http://schemas.openxmlformats.org/officeDocument/2006/relationships" xmlns:p="http://schemas.openxmlformats.org/presentationml/2006/main">
-  <p:cSld>
-    <p:spTree>
-      <p:nvGrpSpPr>
-        <p:cNvPr id="1" name=""/>
-        <p:cNvGrpSpPr/>
-        <p:nvPr/>
-      </p:nvGrpSpPr>
-      <p:grpSpPr>
-        <a:xfrm>
-          <a:off x="0" y="0"/>
-          <a:ext cx="0" cy="0"/>
-          <a:chOff x="0" y="0"/>
-          <a:chExt cx="0" cy="0"/>
-        </a:xfrm>
-      </p:grpSpPr>
       <p:sp>
         <p:nvSpPr>
           <p:cNvPr id="3" name="Rectangle 2"/>
@@ -5145,7 +4806,7 @@
 </p:sld>
 </file>
 
-<file path=ppt/slides/slide5.xml><?xml version="1.0" encoding="utf-8"?>
+<file path=ppt/slides/slide4.xml><?xml version="1.0" encoding="utf-8"?>
 <p:sld xmlns:a="http://schemas.openxmlformats.org/drawingml/2006/main" xmlns:r="http://schemas.openxmlformats.org/officeDocument/2006/relationships" xmlns:p="http://schemas.openxmlformats.org/presentationml/2006/main">
   <p:cSld>
     <p:spTree>
@@ -5167,7 +4828,7 @@
           <p:cNvPr id="2" name="Title 1">
             <a:extLst>
               <a:ext uri="{FF2B5EF4-FFF2-40B4-BE49-F238E27FC236}">
-                <a16:creationId xmlns:a16="http://schemas.microsoft.com/office/drawing/2014/main" id="{16293A8E-BC3C-454C-B050-3E067FFF49B1}"/>
+                <a16:creationId xmlns:a16="http://schemas.microsoft.com/office/drawing/2014/main" id="{C1A72A63-42AD-747B-9919-23832AA401A3}"/>
               </a:ext>
             </a:extLst>
           </p:cNvPr>
@@ -5192,7 +4853,7 @@
           <p:cNvPr id="3" name="Subtitle 2">
             <a:extLst>
               <a:ext uri="{FF2B5EF4-FFF2-40B4-BE49-F238E27FC236}">
-                <a16:creationId xmlns:a16="http://schemas.microsoft.com/office/drawing/2014/main" id="{AF3C6CCF-1D89-A247-BAA5-CFD1DCAC6B92}"/>
+                <a16:creationId xmlns:a16="http://schemas.microsoft.com/office/drawing/2014/main" id="{948AB69B-9853-B478-F12D-2CEFE1076102}"/>
               </a:ext>
             </a:extLst>
           </p:cNvPr>
@@ -5214,10 +4875,10 @@
       </p:sp>
       <p:pic>
         <p:nvPicPr>
-          <p:cNvPr id="5" name="slide.url=https://www.polleverywhere.com/discourses/4S7u0o0hpXopHlnMc1ArI">
-            <a:extLst>
-              <a:ext uri="{FF2B5EF4-FFF2-40B4-BE49-F238E27FC236}">
-                <a16:creationId xmlns:a16="http://schemas.microsoft.com/office/drawing/2014/main" id="{5367478F-22B0-394A-A073-E6DB275FBFBC}"/>
+          <p:cNvPr id="5" name="slide.url=https://www.polleverywhere.com/discourses/oI4gPMkToAhAFAKFma6Sx">
+            <a:extLst>
+              <a:ext uri="{FF2B5EF4-FFF2-40B4-BE49-F238E27FC236}">
+                <a16:creationId xmlns:a16="http://schemas.microsoft.com/office/drawing/2014/main" id="{E9FAAFC3-9089-4119-2C5E-91AC3BDA92B4}"/>
               </a:ext>
             </a:extLst>
           </p:cNvPr>
@@ -5245,7 +4906,7 @@
     </p:spTree>
     <p:extLst>
       <p:ext uri="{BB962C8B-B14F-4D97-AF65-F5344CB8AC3E}">
-        <p14:creationId xmlns:p14="http://schemas.microsoft.com/office/powerpoint/2010/main" val="1318557069"/>
+        <p14:creationId xmlns:p14="http://schemas.microsoft.com/office/powerpoint/2010/main" val="2150417228"/>
       </p:ext>
     </p:extLst>
   </p:cSld>
@@ -5255,7 +4916,7 @@
 </p:sld>
 </file>
 
-<file path=ppt/slides/slide6.xml><?xml version="1.0" encoding="utf-8"?>
+<file path=ppt/slides/slide5.xml><?xml version="1.0" encoding="utf-8"?>
 <p:sld xmlns:a="http://schemas.openxmlformats.org/drawingml/2006/main" xmlns:r="http://schemas.openxmlformats.org/officeDocument/2006/relationships" xmlns:p="http://schemas.openxmlformats.org/presentationml/2006/main">
   <p:cSld>
     <p:spTree>
@@ -5680,132 +5341,7 @@
 </p:sld>
 </file>
 
-<file path=ppt/slides/slide7.xml><?xml version="1.0" encoding="utf-8"?>
-<p:sld xmlns:a="http://schemas.openxmlformats.org/drawingml/2006/main" xmlns:r="http://schemas.openxmlformats.org/officeDocument/2006/relationships" xmlns:p="http://schemas.openxmlformats.org/presentationml/2006/main">
-  <p:cSld>
-    <p:spTree>
-      <p:nvGrpSpPr>
-        <p:cNvPr id="1" name=""/>
-        <p:cNvGrpSpPr/>
-        <p:nvPr/>
-      </p:nvGrpSpPr>
-      <p:grpSpPr>
-        <a:xfrm>
-          <a:off x="0" y="0"/>
-          <a:ext cx="0" cy="0"/>
-          <a:chOff x="0" y="0"/>
-          <a:chExt cx="0" cy="0"/>
-        </a:xfrm>
-      </p:grpSpPr>
-      <p:pic>
-        <p:nvPicPr>
-          <p:cNvPr id="5" name="Picture 4">
-            <a:extLst>
-              <a:ext uri="{FF2B5EF4-FFF2-40B4-BE49-F238E27FC236}">
-                <a16:creationId xmlns:a16="http://schemas.microsoft.com/office/drawing/2014/main" id="{C8F37AE3-B782-4641-8C9A-7A9115E2FD8D}"/>
-              </a:ext>
-            </a:extLst>
-          </p:cNvPr>
-          <p:cNvPicPr>
-            <a:picLocks noChangeAspect="1"/>
-          </p:cNvPicPr>
-          <p:nvPr/>
-        </p:nvPicPr>
-        <p:blipFill rotWithShape="1">
-          <a:blip r:embed="rId3"/>
-          <a:srcRect l="6978" t="6285" r="7095" b="7757"/>
-          <a:stretch/>
-        </p:blipFill>
-        <p:spPr>
-          <a:xfrm>
-            <a:off x="1128713" y="128588"/>
-            <a:ext cx="9929812" cy="6615541"/>
-          </a:xfrm>
-          <a:prstGeom prst="rect">
-            <a:avLst/>
-          </a:prstGeom>
-        </p:spPr>
-      </p:pic>
-      <p:sp>
-        <p:nvSpPr>
-          <p:cNvPr id="6" name="Rectangle 5">
-            <a:extLst>
-              <a:ext uri="{FF2B5EF4-FFF2-40B4-BE49-F238E27FC236}">
-                <a16:creationId xmlns:a16="http://schemas.microsoft.com/office/drawing/2014/main" id="{A39FD90B-DD6A-0047-880B-88E1046FD57D}"/>
-              </a:ext>
-            </a:extLst>
-          </p:cNvPr>
-          <p:cNvSpPr>
-            <a:spLocks noChangeArrowheads="1"/>
-          </p:cNvSpPr>
-          <p:nvPr/>
-        </p:nvSpPr>
-        <p:spPr bwMode="auto">
-          <a:xfrm>
-            <a:off x="271470" y="283451"/>
-            <a:ext cx="11649060" cy="1169551"/>
-          </a:xfrm>
-          <a:prstGeom prst="rect">
-            <a:avLst/>
-          </a:prstGeom>
-          <a:noFill/>
-          <a:ln w="9525">
-            <a:noFill/>
-            <a:miter lim="800000"/>
-            <a:headEnd/>
-            <a:tailEnd/>
-          </a:ln>
-          <a:effectLst/>
-        </p:spPr>
-        <p:txBody>
-          <a:bodyPr wrap="square">
-            <a:spAutoFit/>
-          </a:bodyPr>
-          <a:lstStyle/>
-          <a:p>
-            <a:pPr algn="ctr">
-              <a:defRPr/>
-            </a:pPr>
-            <a:r>
-              <a:rPr lang="en-US" sz="3500" b="1" dirty="0">
-                <a:latin typeface="Avenir"/>
-                <a:cs typeface="Avenir"/>
-              </a:rPr>
-              <a:t>Q3. periodicity in filarial nematode </a:t>
-            </a:r>
-          </a:p>
-          <a:p>
-            <a:pPr algn="ctr">
-              <a:defRPr/>
-            </a:pPr>
-            <a:r>
-              <a:rPr lang="en-US" sz="3500" b="1" dirty="0">
-                <a:latin typeface="Avenir"/>
-                <a:cs typeface="Avenir"/>
-              </a:rPr>
-              <a:t>distribution</a:t>
-            </a:r>
-            <a:endParaRPr lang="en-US" sz="3500" b="1" i="1" dirty="0">
-              <a:latin typeface="Avenir"/>
-              <a:cs typeface="Avenir"/>
-            </a:endParaRPr>
-          </a:p>
-        </p:txBody>
-      </p:sp>
-    </p:spTree>
-    <p:extLst>
-      <p:ext uri="{BB962C8B-B14F-4D97-AF65-F5344CB8AC3E}">
-        <p14:creationId xmlns:p14="http://schemas.microsoft.com/office/powerpoint/2010/main" val="1217805624"/>
-      </p:ext>
-    </p:extLst>
-  </p:cSld>
-  <p:clrMapOvr>
-    <a:masterClrMapping/>
-  </p:clrMapOvr>
-</p:sld>
-</file>
-
-<file path=ppt/slides/slide8.xml><?xml version="1.0" encoding="utf-8"?>
+<file path=ppt/slides/slide6.xml><?xml version="1.0" encoding="utf-8"?>
 <p:sld xmlns:a="http://schemas.openxmlformats.org/drawingml/2006/main" xmlns:r="http://schemas.openxmlformats.org/officeDocument/2006/relationships" xmlns:p="http://schemas.openxmlformats.org/presentationml/2006/main">
   <p:cSld>
     <p:bg>
@@ -5874,7 +5410,7 @@
                 <a:latin typeface="Avenir Book" panose="02000503020000020003" pitchFamily="2" charset="0"/>
                 <a:cs typeface="Avenir"/>
               </a:rPr>
-              <a:t>Practical session 12</a:t>
+              <a:t>Class 12</a:t>
             </a:r>
             <a:r>
               <a:rPr lang="en-US" sz="4800" dirty="0">

</xml_diff>